<commit_message>
Regenerate demo results, theory notes and decks for the 24D x 12D domain (26,444 cells; St 0.207, Cd 1.56, Cl +/-0.71)
Co-authored-by: Wahengbam <ichanwaheng@users.noreply.github.com>
</commit_message>
<xml_diff>
--- a/cylinder_re150/demo/ns_staggered_12_steps.pptx
+++ b/cylinder_re150/demo/ns_staggered_12_steps.pptx
@@ -3238,7 +3238,7 @@
         <p:spPr>
           <a:xfrm>
             <a:off x="6675120" y="3566160"/>
-            <a:ext cx="2920959" cy="3017520"/>
+            <a:ext cx="2804282" cy="3017520"/>
           </a:xfrm>
           <a:prstGeom prst="rect">
             <a:avLst/>
@@ -4288,7 +4288,7 @@
                   <a:srgbClr val="555555"/>
                 </a:solidFill>
               </a:rPr>
-              <a:t>• A small seed one diameter behind the cylinder brings the onset to tU/D ≈ 20 — the right plot; both end on the same limit cycle (Cl ± 0.75)</a:t>
+              <a:t>• A small seed one diameter behind the cylinder brings the onset to tU/D ≈ 20 — the right plot; both end on the same limit cycle (earlier 40 D × 10 D domain; Cl ± 0.75)</a:t>
             </a:r>
           </a:p>
         </p:txBody>
@@ -4361,7 +4361,7 @@
       </p:sp>
       <p:pic>
         <p:nvPicPr>
-          <p:cNvPr id="6" name="Picture 5" descr="forces_central_fine.png"/>
+          <p:cNvPr id="6" name="Picture 5" descr="forces_noseed_40x10.png"/>
           <p:cNvPicPr>
             <a:picLocks noChangeAspect="1"/>
           </p:cNvPicPr>
@@ -4385,7 +4385,7 @@
       </p:pic>
       <p:pic>
         <p:nvPicPr>
-          <p:cNvPr id="7" name="Picture 6" descr="forces_central_fine_default_run.png"/>
+          <p:cNvPr id="7" name="Picture 6" descr="forces_seed_40x10.png"/>
           <p:cNvPicPr>
             <a:picLocks noChangeAspect="1"/>
           </p:cNvPicPr>
@@ -4824,7 +4824,7 @@
                   <a:srgbClr val="555555"/>
                 </a:solidFill>
               </a:rPr>
-              <a:t>• Fine mesh, central: after the impulsive transient Cl grows exponentially and saturates at ± 0.75 by tU/D ≈ 30</a:t>
+              <a:t>• Fine mesh, central: after the impulsive transient Cl grows exponentially and saturates at ± 0.71 by tU/D ≈ 30</a:t>
             </a:r>
           </a:p>
           <a:p>
@@ -4839,7 +4839,7 @@
                   <a:srgbClr val="555555"/>
                 </a:solidFill>
               </a:rPr>
-              <a:t>• Period 1/St ≈ 4.8 → St ≈ 0.20–0.21;  Cd ≈ 1.64 oscillating at twice the lift frequency</a:t>
+              <a:t>• Period 1/St ≈ 4.8 → St ≈ 0.21;  Cd ≈ 1.56 oscillating at twice the lift frequency</a:t>
             </a:r>
           </a:p>
           <a:p>
@@ -4854,7 +4854,7 @@
                   <a:srgbClr val="555555"/>
                 </a:solidFill>
               </a:rPr>
-              <a:t>• Unbounded-cylinder references: St ≈ 0.18, Cd ≈ 1.33 — the 10 % blockage of the ±5 D channel and first-order Euler push both up</a:t>
+              <a:t>• Unbounded-cylinder references: St ≈ 0.18, Cd ≈ 1.33 — the 8.3 % blockage of the 12 D-high channel and first-order Euler push both up</a:t>
             </a:r>
           </a:p>
           <a:p>
@@ -4923,7 +4923,7 @@
                 </a:solidFill>
                 <a:latin typeface="Courier New"/>
               </a:rPr>
-              <a:t>forces   : Cd_mean=1.643  Cl_amp=0.751  St=0.213</a:t>
+              <a:t>forces   : Cd_mean=1.564  Cl_amp=0.712  St=0.207</a:t>
             </a:r>
           </a:p>
         </p:txBody>
@@ -5201,7 +5201,7 @@
                   <a:srgbClr val="555555"/>
                 </a:solidFill>
               </a:rPr>
-              <a:t>• Bottom: u − U∞ — free stream white, wake (slower) blue, shoulders (faster) red; arrows = (u_P, v_P) in the sampled cells</a:t>
+              <a:t>• Bottom, 'Velocity plot': the speed |u| — free stream ≈ 1, wake (slow) dark, shoulders (fast) bright; arrows = (u_P, v_P) in the sampled cells</a:t>
             </a:r>
           </a:p>
           <a:p>
@@ -5268,7 +5268,7 @@
         <p:spPr>
           <a:xfrm>
             <a:off x="6766560" y="1234440"/>
-            <a:ext cx="4868266" cy="5029200"/>
+            <a:ext cx="4673803" cy="5029200"/>
           </a:xfrm>
           <a:prstGeom prst="rect">
             <a:avLst/>
@@ -5918,7 +5918,7 @@
                     <a:p>
                       <a:r>
                         <a:rPr sz="1200"/>
-                        <a:t>Cl ±0.75, St 0.20, Cd 1.64</a:t>
+                        <a:t>Cl ±0.71, St 0.21, Cd 1.56</a:t>
                       </a:r>
                     </a:p>
                   </a:txBody>
@@ -6162,7 +6162,7 @@
                   <a:srgbClr val="555555"/>
                 </a:solidFill>
               </a:rPr>
-              <a:t>• Mesh from mesh_from_known_sizes.py: O-ring + transition + Cartesian blocks, 37,044 cells (d_min = 0.015)</a:t>
+              <a:t>• Mesh from mesh_from_known_sizes.py: O-ring + transition + Cartesian blocks, 26,444 cells (d_min = 0.015)</a:t>
             </a:r>
           </a:p>
           <a:p>
@@ -6343,7 +6343,7 @@
         <p:spPr>
           <a:xfrm>
             <a:off x="6583680" y="1280160"/>
-            <a:ext cx="5303520" cy="2542461"/>
+            <a:ext cx="5303520" cy="2568521"/>
           </a:xfrm>
           <a:prstGeom prst="rect">
             <a:avLst/>
@@ -8912,7 +8912,7 @@
                   <a:srgbClr val="555555"/>
                 </a:solidFill>
               </a:rPr>
-              <a:t>• inlet x = −10 D: u = U∞ (+ a short transverse pulse, Step 10);  outlet x = +30 D: ∂u/∂n = 0;  walls y = ±5 D and cylinder: u = 0</a:t>
+              <a:t>• inlet x = 0: u = U∞ (+ a short transverse pulse, Step 10);  outlet x = 24 D: ∂u/∂n = 0;  walls y = 0, 12 D and cylinder (centre 6 D, 6 D): u = 0</a:t>
             </a:r>
           </a:p>
           <a:p>

</xml_diff>